<commit_message>
deck v4: six film stills (Luna), image check, review renders
Co-Authored-By: Claude Opus 5.5 <noreply@anthropic.com>
Claude-Session: https://claude.ai/code/session_01CcKic77nKguzkLw3T8mxtp
</commit_message>
<xml_diff>
--- a/deck/CPR_Coach_Anvathon_2026_v4.pptx
+++ b/deck/CPR_Coach_Anvathon_2026_v4.pptx
@@ -120,12 +120,12 @@
   <p:extLst>
     <p:ext uri="{521415D9-36F7-43E2-AB2F-B90AF26B5E84}">
       <p14:sectionLst xmlns:p14="http://schemas.microsoft.com/office/powerpoint/2010/main">
-        <p14:section name="Opening" id="{f6c2bde9-6297-07e3-d879-5b17fc08dd2f}">
+        <p14:section name="Opening" id="{5eabf9ba-d429-1fd8-9338-08a971bb22c0}">
           <p14:sldIdLst>
             <p14:sldId id="256"/>
           </p14:sldIdLst>
         </p14:section>
-        <p14:section name="Problem" id="{3f0f8bda-7b8e-98aa-ba1b-705c45b9d46b}">
+        <p14:section name="Problem" id="{9b4b3b73-4d3d-f324-6334-bfd3cdc747d0}">
           <p14:sldIdLst>
             <p14:sldId id="257"/>
             <p14:sldId id="258"/>
@@ -133,7 +133,7 @@
             <p14:sldId id="260"/>
           </p14:sldIdLst>
         </p14:section>
-        <p14:section name="Solution" id="{1d11a63a-a8b2-f095-b7b6-4745369fb8ec}">
+        <p14:section name="Solution" id="{86baf314-6a1b-5488-d805-5acc4710e4e0}">
           <p14:sldIdLst>
             <p14:sldId id="261"/>
             <p14:sldId id="262"/>
@@ -142,18 +142,18 @@
             <p14:sldId id="265"/>
           </p14:sldIdLst>
         </p14:section>
-        <p14:section name="Demo" id="{0afb88d3-41b5-0d84-c6cf-ffa2f1292a9f}">
+        <p14:section name="Demo" id="{127973ab-7884-67ac-e78a-e8950d7c0a81}">
           <p14:sldIdLst>
             <p14:sldId id="266"/>
           </p14:sldIdLst>
         </p14:section>
-        <p14:section name="Evidence" id="{35ae9a2a-296b-a4fe-b1b0-b1abc4944f1e}">
+        <p14:section name="Evidence" id="{8d7179cd-3d42-d5c8-bc96-a81938161765}">
           <p14:sldIdLst>
             <p14:sldId id="267"/>
             <p14:sldId id="268"/>
           </p14:sldIdLst>
         </p14:section>
-        <p14:section name="Close" id="{873ab4e6-a455-59e8-b65b-b82919a554c2}">
+        <p14:section name="Close" id="{22416e20-dac8-2a55-5d37-220dae28d772}">
           <p14:sldIdLst>
             <p14:sldId id="269"/>
           </p14:sldIdLst>
@@ -2931,6 +2931,20 @@
 <file path=ppt/slides/slide10.xml><?xml version="1.0" encoding="utf-8"?>
 <p:sld xmlns:a="http://schemas.openxmlformats.org/drawingml/2006/main" xmlns:r="http://schemas.openxmlformats.org/officeDocument/2006/relationships" xmlns:p="http://schemas.openxmlformats.org/presentationml/2006/main">
   <p:cSld name="Slide 10">
+    <p:bg>
+      <p:bgPr>
+        <a:blipFill dpi="0" rotWithShape="1">
+          <a:blip r:embed="rId1">
+            <a:lum/>
+          </a:blip>
+          <a:srcRect/>
+          <a:stretch>
+            <a:fillRect/>
+          </a:stretch>
+        </a:blipFill>
+        <a:effectLst/>
+      </p:bgPr>
+    </p:bg>
     <p:spTree>
       <p:nvGrpSpPr>
         <p:cNvPr id="1" name=""/>
@@ -2947,7 +2961,29 @@
       </p:grpSpPr>
       <p:sp>
         <p:nvSpPr>
-          <p:cNvPr id="2" name="Text 0"/>
+          <p:cNvPr id="2" name="Shape 0"/>
+          <p:cNvSpPr/>
+          <p:nvPr/>
+        </p:nvSpPr>
+        <p:spPr>
+          <a:xfrm>
+            <a:off x="0" y="0"/>
+            <a:ext cx="12191695" cy="6858000"/>
+          </a:xfrm>
+          <a:prstGeom prst="rect">
+            <a:avLst/>
+          </a:prstGeom>
+          <a:solidFill>
+            <a:srgbClr val="0E1418">
+              <a:alpha val="65000"/>
+            </a:srgbClr>
+          </a:solidFill>
+          <a:ln/>
+        </p:spPr>
+      </p:sp>
+      <p:sp>
+        <p:nvSpPr>
+          <p:cNvPr id="3" name="Text 0"/>
           <p:cNvSpPr/>
           <p:nvPr>
             <p:ph idx="100" type="title" hasCustomPrompt="1"/>
@@ -2988,7 +3024,43 @@
       </p:sp>
       <p:sp>
         <p:nvSpPr>
-          <p:cNvPr id="3" name="Text 1"/>
+          <p:cNvPr id="4" name="Text 2"/>
+          <p:cNvSpPr txBox="1"/>
+          <p:nvPr/>
+        </p:nvSpPr>
+        <p:spPr>
+          <a:xfrm>
+            <a:off x="9966960" y="164592"/>
+            <a:ext cx="1536192" cy="274320"/>
+          </a:xfrm>
+          <a:prstGeom prst="rect">
+            <a:avLst/>
+          </a:prstGeom>
+          <a:noFill/>
+          <a:ln/>
+        </p:spPr>
+        <p:txBody>
+          <a:bodyPr wrap="square" lIns="0" tIns="0" rIns="0" bIns="0" rtlCol="0" anchor="t"/>
+          <a:lstStyle/>
+          <a:p>
+            <a:pPr algn="r" indent="0" marL="0">
+              <a:buNone/>
+            </a:pPr>
+            <a:r>
+              <a:rPr lang="en-US" sz="1200" i="1" dirty="0">
+                <a:solidFill>
+                  <a:schemeClr val="bg2"/>
+                </a:solidFill>
+              </a:rPr>
+              <a:t>Illustration</a:t>
+            </a:r>
+            <a:endParaRPr lang="en-US" sz="1200" dirty="0"/>
+          </a:p>
+        </p:txBody>
+      </p:sp>
+      <p:sp>
+        <p:nvSpPr>
+          <p:cNvPr id="5" name="Text 3"/>
           <p:cNvSpPr txBox="1"/>
           <p:nvPr/>
         </p:nvSpPr>
@@ -3027,7 +3099,7 @@
       </p:sp>
       <p:sp>
         <p:nvSpPr>
-          <p:cNvPr id="4" name="Text 2"/>
+          <p:cNvPr id="6" name="Text 4"/>
           <p:cNvSpPr txBox="1"/>
           <p:nvPr/>
         </p:nvSpPr>
@@ -3066,7 +3138,7 @@
       </p:sp>
       <p:sp>
         <p:nvSpPr>
-          <p:cNvPr id="5" name="Text 3"/>
+          <p:cNvPr id="7" name="Text 5"/>
           <p:cNvSpPr txBox="1"/>
           <p:nvPr/>
         </p:nvSpPr>
@@ -3105,7 +3177,7 @@
       </p:sp>
       <p:sp>
         <p:nvSpPr>
-          <p:cNvPr id="6" name="Text 4"/>
+          <p:cNvPr id="8" name="Text 6"/>
           <p:cNvSpPr txBox="1"/>
           <p:nvPr/>
         </p:nvSpPr>
@@ -3144,7 +3216,7 @@
       </p:sp>
       <p:sp>
         <p:nvSpPr>
-          <p:cNvPr id="7" name="Text 5"/>
+          <p:cNvPr id="9" name="Text 7"/>
           <p:cNvSpPr txBox="1"/>
           <p:nvPr/>
         </p:nvSpPr>
@@ -3183,7 +3255,7 @@
       </p:sp>
       <p:sp>
         <p:nvSpPr>
-          <p:cNvPr id="8" name="Text 6"/>
+          <p:cNvPr id="10" name="Text 8"/>
           <p:cNvSpPr txBox="1"/>
           <p:nvPr/>
         </p:nvSpPr>
@@ -3222,7 +3294,7 @@
       </p:sp>
       <p:sp>
         <p:nvSpPr>
-          <p:cNvPr id="9" name="Text 7"/>
+          <p:cNvPr id="11" name="Text 9"/>
           <p:cNvSpPr txBox="1"/>
           <p:nvPr/>
         </p:nvSpPr>
@@ -3261,7 +3333,7 @@
       </p:sp>
       <p:sp>
         <p:nvSpPr>
-          <p:cNvPr id="10" name="Text 8"/>
+          <p:cNvPr id="12" name="Text 10"/>
           <p:cNvSpPr txBox="1"/>
           <p:nvPr/>
         </p:nvSpPr>
@@ -3300,7 +3372,7 @@
       </p:sp>
       <p:sp>
         <p:nvSpPr>
-          <p:cNvPr id="11" name="Text 9"/>
+          <p:cNvPr id="13" name="Text 11"/>
           <p:cNvSpPr txBox="1"/>
           <p:nvPr/>
         </p:nvSpPr>
@@ -3339,7 +3411,7 @@
       </p:sp>
       <p:sp>
         <p:nvSpPr>
-          <p:cNvPr id="12" name="Text 10"/>
+          <p:cNvPr id="14" name="Text 12"/>
           <p:cNvSpPr txBox="1"/>
           <p:nvPr/>
         </p:nvSpPr>
@@ -3378,7 +3450,7 @@
       </p:sp>
       <p:sp>
         <p:nvSpPr>
-          <p:cNvPr id="13" name="Text 11"/>
+          <p:cNvPr id="15" name="Text 13"/>
           <p:cNvSpPr txBox="1"/>
           <p:nvPr/>
         </p:nvSpPr>
@@ -4811,6 +4883,20 @@
 <file path=ppt/slides/slide14.xml><?xml version="1.0" encoding="utf-8"?>
 <p:sld xmlns:a="http://schemas.openxmlformats.org/drawingml/2006/main" xmlns:r="http://schemas.openxmlformats.org/officeDocument/2006/relationships" xmlns:p="http://schemas.openxmlformats.org/presentationml/2006/main">
   <p:cSld name="Slide 14">
+    <p:bg>
+      <p:bgPr>
+        <a:blipFill dpi="0" rotWithShape="1">
+          <a:blip r:embed="rId1">
+            <a:lum/>
+          </a:blip>
+          <a:srcRect/>
+          <a:stretch>
+            <a:fillRect/>
+          </a:stretch>
+        </a:blipFill>
+        <a:effectLst/>
+      </p:bgPr>
+    </p:bg>
     <p:spTree>
       <p:nvGrpSpPr>
         <p:cNvPr id="1" name=""/>
@@ -4827,7 +4913,29 @@
       </p:grpSpPr>
       <p:sp>
         <p:nvSpPr>
-          <p:cNvPr id="2" name="Text 0"/>
+          <p:cNvPr id="2" name="Shape 0"/>
+          <p:cNvSpPr/>
+          <p:nvPr/>
+        </p:nvSpPr>
+        <p:spPr>
+          <a:xfrm>
+            <a:off x="0" y="0"/>
+            <a:ext cx="12191695" cy="6858000"/>
+          </a:xfrm>
+          <a:prstGeom prst="rect">
+            <a:avLst/>
+          </a:prstGeom>
+          <a:solidFill>
+            <a:srgbClr val="0E1418">
+              <a:alpha val="70000"/>
+            </a:srgbClr>
+          </a:solidFill>
+          <a:ln/>
+        </p:spPr>
+      </p:sp>
+      <p:sp>
+        <p:nvSpPr>
+          <p:cNvPr id="3" name="Text 0"/>
           <p:cNvSpPr/>
           <p:nvPr>
             <p:ph idx="100" type="title" hasCustomPrompt="1"/>
@@ -4885,7 +4993,43 @@
       </p:sp>
       <p:sp>
         <p:nvSpPr>
-          <p:cNvPr id="3" name="Text 1"/>
+          <p:cNvPr id="4" name="Text 2"/>
+          <p:cNvSpPr txBox="1"/>
+          <p:nvPr/>
+        </p:nvSpPr>
+        <p:spPr>
+          <a:xfrm>
+            <a:off x="9966960" y="164592"/>
+            <a:ext cx="1536192" cy="274320"/>
+          </a:xfrm>
+          <a:prstGeom prst="rect">
+            <a:avLst/>
+          </a:prstGeom>
+          <a:noFill/>
+          <a:ln/>
+        </p:spPr>
+        <p:txBody>
+          <a:bodyPr wrap="square" lIns="0" tIns="0" rIns="0" bIns="0" rtlCol="0" anchor="t"/>
+          <a:lstStyle/>
+          <a:p>
+            <a:pPr algn="r" indent="0" marL="0">
+              <a:buNone/>
+            </a:pPr>
+            <a:r>
+              <a:rPr lang="en-US" sz="1200" i="1" dirty="0">
+                <a:solidFill>
+                  <a:schemeClr val="bg2"/>
+                </a:solidFill>
+              </a:rPr>
+              <a:t>Illustration</a:t>
+            </a:r>
+            <a:endParaRPr lang="en-US" sz="1200" dirty="0"/>
+          </a:p>
+        </p:txBody>
+      </p:sp>
+      <p:sp>
+        <p:nvSpPr>
+          <p:cNvPr id="5" name="Text 3"/>
           <p:cNvSpPr txBox="1"/>
           <p:nvPr/>
         </p:nvSpPr>
@@ -4921,31 +5065,7 @@
       </p:sp>
       <p:pic>
         <p:nvPicPr>
-          <p:cNvPr id="4" name="Image 0" descr="A slow amber rhythm corrected into a steady teal rhythm">    </p:cNvPr>
-          <p:cNvPicPr>
-            <a:picLocks noChangeAspect="1"/>
-          </p:cNvPicPr>
-          <p:nvPr/>
-        </p:nvPicPr>
-        <p:blipFill>
-          <a:blip r:embed="rId1"/>
-          <a:stretch>
-            <a:fillRect/>
-          </a:stretch>
-        </p:blipFill>
-        <p:spPr>
-          <a:xfrm>
-            <a:off x="685800" y="3017520"/>
-            <a:ext cx="7013448" cy="667512"/>
-          </a:xfrm>
-          <a:prstGeom prst="rect">
-            <a:avLst/>
-          </a:prstGeom>
-        </p:spPr>
-      </p:pic>
-      <p:pic>
-        <p:nvPicPr>
-          <p:cNvPr id="5" name="Image 1" descr="QR code linking to github.com/VivekTiwary-25/Zero_flux">    </p:cNvPr>
+          <p:cNvPr id="6" name="Image 0" descr="A slow amber rhythm corrected into a steady teal rhythm">    </p:cNvPr>
           <p:cNvPicPr>
             <a:picLocks noChangeAspect="1"/>
           </p:cNvPicPr>
@@ -4959,6 +5079,30 @@
         </p:blipFill>
         <p:spPr>
           <a:xfrm>
+            <a:off x="685800" y="3017520"/>
+            <a:ext cx="7013448" cy="667512"/>
+          </a:xfrm>
+          <a:prstGeom prst="rect">
+            <a:avLst/>
+          </a:prstGeom>
+        </p:spPr>
+      </p:pic>
+      <p:pic>
+        <p:nvPicPr>
+          <p:cNvPr id="7" name="Image 1" descr="QR code linking to github.com/VivekTiwary-25/Zero_flux">    </p:cNvPr>
+          <p:cNvPicPr>
+            <a:picLocks noChangeAspect="1"/>
+          </p:cNvPicPr>
+          <p:nvPr/>
+        </p:nvPicPr>
+        <p:blipFill>
+          <a:blip r:embed="rId3"/>
+          <a:stretch>
+            <a:fillRect/>
+          </a:stretch>
+        </p:blipFill>
+        <p:spPr>
+          <a:xfrm>
             <a:off x="9006840" y="1965960"/>
             <a:ext cx="2496312" cy="2496312"/>
           </a:xfrm>
@@ -4969,7 +5113,7 @@
       </p:pic>
       <p:sp>
         <p:nvSpPr>
-          <p:cNvPr id="6" name="Text 2"/>
+          <p:cNvPr id="8" name="Text 4"/>
           <p:cNvSpPr txBox="1"/>
           <p:nvPr/>
         </p:nvSpPr>
@@ -5005,7 +5149,7 @@
       </p:sp>
       <p:sp>
         <p:nvSpPr>
-          <p:cNvPr id="7" name="Text 3"/>
+          <p:cNvPr id="9" name="Text 5"/>
           <p:cNvSpPr txBox="1"/>
           <p:nvPr/>
         </p:nvSpPr>
@@ -5044,7 +5188,7 @@
       </p:sp>
       <p:sp>
         <p:nvSpPr>
-          <p:cNvPr id="8" name="Text 4"/>
+          <p:cNvPr id="10" name="Text 6"/>
           <p:cNvSpPr txBox="1"/>
           <p:nvPr/>
         </p:nvSpPr>
@@ -5091,7 +5235,7 @@
       </p:sp>
       <p:sp>
         <p:nvSpPr>
-          <p:cNvPr id="9" name="Text 5"/>
+          <p:cNvPr id="11" name="Text 7"/>
           <p:cNvSpPr txBox="1"/>
           <p:nvPr/>
         </p:nvSpPr>
@@ -5195,6 +5339,20 @@
 <file path=ppt/slides/slide2.xml><?xml version="1.0" encoding="utf-8"?>
 <p:sld xmlns:a="http://schemas.openxmlformats.org/drawingml/2006/main" xmlns:r="http://schemas.openxmlformats.org/officeDocument/2006/relationships" xmlns:p="http://schemas.openxmlformats.org/presentationml/2006/main">
   <p:cSld name="Slide 2">
+    <p:bg>
+      <p:bgPr>
+        <a:blipFill dpi="0" rotWithShape="1">
+          <a:blip r:embed="rId1">
+            <a:lum/>
+          </a:blip>
+          <a:srcRect/>
+          <a:stretch>
+            <a:fillRect/>
+          </a:stretch>
+        </a:blipFill>
+        <a:effectLst/>
+      </p:bgPr>
+    </p:bg>
     <p:spTree>
       <p:nvGrpSpPr>
         <p:cNvPr id="1" name=""/>
@@ -5211,7 +5369,29 @@
       </p:grpSpPr>
       <p:sp>
         <p:nvSpPr>
-          <p:cNvPr id="2" name="Text 0"/>
+          <p:cNvPr id="2" name="Shape 0"/>
+          <p:cNvSpPr/>
+          <p:nvPr/>
+        </p:nvSpPr>
+        <p:spPr>
+          <a:xfrm>
+            <a:off x="0" y="0"/>
+            <a:ext cx="12191695" cy="6858000"/>
+          </a:xfrm>
+          <a:prstGeom prst="rect">
+            <a:avLst/>
+          </a:prstGeom>
+          <a:solidFill>
+            <a:srgbClr val="0E1418">
+              <a:alpha val="60000"/>
+            </a:srgbClr>
+          </a:solidFill>
+          <a:ln/>
+        </p:spPr>
+      </p:sp>
+      <p:sp>
+        <p:nvSpPr>
+          <p:cNvPr id="3" name="Text 0"/>
           <p:cNvSpPr/>
           <p:nvPr>
             <p:ph idx="100" type="title" hasCustomPrompt="1"/>
@@ -5252,7 +5432,43 @@
       </p:sp>
       <p:sp>
         <p:nvSpPr>
-          <p:cNvPr id="3" name="Text 1"/>
+          <p:cNvPr id="4" name="Text 2"/>
+          <p:cNvSpPr txBox="1"/>
+          <p:nvPr/>
+        </p:nvSpPr>
+        <p:spPr>
+          <a:xfrm>
+            <a:off x="9966960" y="164592"/>
+            <a:ext cx="1536192" cy="274320"/>
+          </a:xfrm>
+          <a:prstGeom prst="rect">
+            <a:avLst/>
+          </a:prstGeom>
+          <a:noFill/>
+          <a:ln/>
+        </p:spPr>
+        <p:txBody>
+          <a:bodyPr wrap="square" lIns="0" tIns="0" rIns="0" bIns="0" rtlCol="0" anchor="t"/>
+          <a:lstStyle/>
+          <a:p>
+            <a:pPr algn="r" indent="0" marL="0">
+              <a:buNone/>
+            </a:pPr>
+            <a:r>
+              <a:rPr lang="en-US" sz="1200" i="1" dirty="0">
+                <a:solidFill>
+                  <a:schemeClr val="bg2"/>
+                </a:solidFill>
+              </a:rPr>
+              <a:t>Illustration</a:t>
+            </a:r>
+            <a:endParaRPr lang="en-US" sz="1200" dirty="0"/>
+          </a:p>
+        </p:txBody>
+      </p:sp>
+      <p:sp>
+        <p:nvSpPr>
+          <p:cNvPr id="5" name="Text 3"/>
           <p:cNvSpPr txBox="1"/>
           <p:nvPr/>
         </p:nvSpPr>
@@ -5291,7 +5507,7 @@
       </p:sp>
       <p:sp>
         <p:nvSpPr>
-          <p:cNvPr id="4" name="Text 2"/>
+          <p:cNvPr id="6" name="Text 4"/>
           <p:cNvSpPr txBox="1"/>
           <p:nvPr/>
         </p:nvSpPr>
@@ -5369,14 +5585,14 @@
       </p:sp>
       <p:pic>
         <p:nvPicPr>
-          <p:cNvPr id="5" name="Image 0" descr="A flat line: nobody is pushing">    </p:cNvPr>
+          <p:cNvPr id="7" name="Image 0" descr="A flat line: nobody is pushing">    </p:cNvPr>
           <p:cNvPicPr>
             <a:picLocks noChangeAspect="1"/>
           </p:cNvPicPr>
           <p:nvPr/>
         </p:nvPicPr>
         <p:blipFill>
-          <a:blip r:embed="rId1"/>
+          <a:blip r:embed="rId2"/>
           <a:stretch>
             <a:fillRect/>
           </a:stretch>
@@ -5393,7 +5609,7 @@
       </p:pic>
       <p:sp>
         <p:nvSpPr>
-          <p:cNvPr id="6" name="Text 3"/>
+          <p:cNvPr id="8" name="Text 5"/>
           <p:cNvSpPr txBox="1"/>
           <p:nvPr/>
         </p:nvSpPr>
@@ -5432,7 +5648,7 @@
       </p:sp>
       <p:sp>
         <p:nvSpPr>
-          <p:cNvPr id="7" name="Text 4"/>
+          <p:cNvPr id="9" name="Text 6"/>
           <p:cNvSpPr txBox="1"/>
           <p:nvPr/>
         </p:nvSpPr>
@@ -8472,6 +8688,20 @@
 <file path=ppt/slides/slide8.xml><?xml version="1.0" encoding="utf-8"?>
 <p:sld xmlns:a="http://schemas.openxmlformats.org/drawingml/2006/main" xmlns:r="http://schemas.openxmlformats.org/officeDocument/2006/relationships" xmlns:p="http://schemas.openxmlformats.org/presentationml/2006/main">
   <p:cSld name="Slide 8">
+    <p:bg>
+      <p:bgPr>
+        <a:blipFill dpi="0" rotWithShape="1">
+          <a:blip r:embed="rId1">
+            <a:lum/>
+          </a:blip>
+          <a:srcRect/>
+          <a:stretch>
+            <a:fillRect/>
+          </a:stretch>
+        </a:blipFill>
+        <a:effectLst/>
+      </p:bgPr>
+    </p:bg>
     <p:spTree>
       <p:nvGrpSpPr>
         <p:cNvPr id="1" name=""/>
@@ -8488,7 +8718,29 @@
       </p:grpSpPr>
       <p:sp>
         <p:nvSpPr>
-          <p:cNvPr id="2" name="Text 0"/>
+          <p:cNvPr id="2" name="Shape 0"/>
+          <p:cNvSpPr/>
+          <p:nvPr/>
+        </p:nvSpPr>
+        <p:spPr>
+          <a:xfrm>
+            <a:off x="0" y="0"/>
+            <a:ext cx="12191695" cy="6858000"/>
+          </a:xfrm>
+          <a:prstGeom prst="rect">
+            <a:avLst/>
+          </a:prstGeom>
+          <a:solidFill>
+            <a:srgbClr val="0E1418">
+              <a:alpha val="60000"/>
+            </a:srgbClr>
+          </a:solidFill>
+          <a:ln/>
+        </p:spPr>
+      </p:sp>
+      <p:sp>
+        <p:nvSpPr>
+          <p:cNvPr id="3" name="Text 0"/>
           <p:cNvSpPr/>
           <p:nvPr>
             <p:ph idx="100" type="title" hasCustomPrompt="1"/>
@@ -8529,7 +8781,43 @@
       </p:sp>
       <p:sp>
         <p:nvSpPr>
-          <p:cNvPr id="3" name="Shape 1"/>
+          <p:cNvPr id="4" name="Text 2"/>
+          <p:cNvSpPr txBox="1"/>
+          <p:nvPr/>
+        </p:nvSpPr>
+        <p:spPr>
+          <a:xfrm>
+            <a:off x="9966960" y="164592"/>
+            <a:ext cx="1536192" cy="274320"/>
+          </a:xfrm>
+          <a:prstGeom prst="rect">
+            <a:avLst/>
+          </a:prstGeom>
+          <a:noFill/>
+          <a:ln/>
+        </p:spPr>
+        <p:txBody>
+          <a:bodyPr wrap="square" lIns="0" tIns="0" rIns="0" bIns="0" rtlCol="0" anchor="t"/>
+          <a:lstStyle/>
+          <a:p>
+            <a:pPr algn="r" indent="0" marL="0">
+              <a:buNone/>
+            </a:pPr>
+            <a:r>
+              <a:rPr lang="en-US" sz="1200" i="1" dirty="0">
+                <a:solidFill>
+                  <a:schemeClr val="bg2"/>
+                </a:solidFill>
+              </a:rPr>
+              <a:t>Illustration</a:t>
+            </a:r>
+            <a:endParaRPr lang="en-US" sz="1200" dirty="0"/>
+          </a:p>
+        </p:txBody>
+      </p:sp>
+      <p:sp>
+        <p:nvSpPr>
+          <p:cNvPr id="5" name="Shape 3"/>
           <p:cNvSpPr/>
           <p:nvPr/>
         </p:nvSpPr>
@@ -8552,7 +8840,7 @@
       </p:sp>
       <p:sp>
         <p:nvSpPr>
-          <p:cNvPr id="4" name="Text 2"/>
+          <p:cNvPr id="6" name="Text 4"/>
           <p:cNvSpPr txBox="1"/>
           <p:nvPr/>
         </p:nvSpPr>
@@ -8591,7 +8879,7 @@
       </p:sp>
       <p:sp>
         <p:nvSpPr>
-          <p:cNvPr id="5" name="Text 3"/>
+          <p:cNvPr id="7" name="Text 5"/>
           <p:cNvSpPr txBox="1"/>
           <p:nvPr/>
         </p:nvSpPr>
@@ -8630,7 +8918,7 @@
       </p:sp>
       <p:sp>
         <p:nvSpPr>
-          <p:cNvPr id="6" name="Text 4"/>
+          <p:cNvPr id="8" name="Text 6"/>
           <p:cNvSpPr txBox="1"/>
           <p:nvPr/>
         </p:nvSpPr>
@@ -8703,7 +8991,7 @@
       </p:sp>
       <p:sp>
         <p:nvSpPr>
-          <p:cNvPr id="7" name="Text 5"/>
+          <p:cNvPr id="9" name="Text 7"/>
           <p:cNvSpPr txBox="1"/>
           <p:nvPr/>
         </p:nvSpPr>
@@ -8742,7 +9030,7 @@
       </p:sp>
       <p:sp>
         <p:nvSpPr>
-          <p:cNvPr id="8" name="Text 6"/>
+          <p:cNvPr id="10" name="Text 8"/>
           <p:cNvSpPr txBox="1"/>
           <p:nvPr/>
         </p:nvSpPr>
@@ -8781,7 +9069,7 @@
       </p:sp>
       <p:sp>
         <p:nvSpPr>
-          <p:cNvPr id="9" name="Text 7"/>
+          <p:cNvPr id="11" name="Text 9"/>
           <p:cNvSpPr txBox="1"/>
           <p:nvPr/>
         </p:nvSpPr>
@@ -8820,7 +9108,7 @@
       </p:sp>
       <p:sp>
         <p:nvSpPr>
-          <p:cNvPr id="10" name="Text 8"/>
+          <p:cNvPr id="12" name="Text 10"/>
           <p:cNvSpPr txBox="1"/>
           <p:nvPr/>
         </p:nvSpPr>
@@ -8893,7 +9181,7 @@
       </p:sp>
       <p:sp>
         <p:nvSpPr>
-          <p:cNvPr id="11" name="Text 9"/>
+          <p:cNvPr id="13" name="Text 11"/>
           <p:cNvSpPr txBox="1"/>
           <p:nvPr/>
         </p:nvSpPr>

</xml_diff>

<commit_message>
deck v4: lighter film slides, readable caveats, notes carry detail
Co-Authored-By: Claude Opus 5.5 <noreply@anthropic.com>
Claude-Session: https://claude.ai/code/session_01CcKic77nKguzkLw3T8mxtp
</commit_message>
<xml_diff>
--- a/deck/CPR_Coach_Anvathon_2026_v4.pptx
+++ b/deck/CPR_Coach_Anvathon_2026_v4.pptx
@@ -120,12 +120,12 @@
   <p:extLst>
     <p:ext uri="{521415D9-36F7-43E2-AB2F-B90AF26B5E84}">
       <p14:sectionLst xmlns:p14="http://schemas.microsoft.com/office/powerpoint/2010/main">
-        <p14:section name="Opening" id="{5eabf9ba-d429-1fd8-9338-08a971bb22c0}">
+        <p14:section name="Opening" id="{8913b82e-b6ee-46e6-ec8d-61313e921939}">
           <p14:sldIdLst>
             <p14:sldId id="256"/>
           </p14:sldIdLst>
         </p14:section>
-        <p14:section name="Problem" id="{9b4b3b73-4d3d-f324-6334-bfd3cdc747d0}">
+        <p14:section name="Problem" id="{a7b8e45b-d89e-3fd2-a8ac-b5ebde548a29}">
           <p14:sldIdLst>
             <p14:sldId id="257"/>
             <p14:sldId id="258"/>
@@ -133,7 +133,7 @@
             <p14:sldId id="260"/>
           </p14:sldIdLst>
         </p14:section>
-        <p14:section name="Solution" id="{86baf314-6a1b-5488-d805-5acc4710e4e0}">
+        <p14:section name="Solution" id="{d50a745f-bafc-b0dc-bd2f-b1f3c2595520}">
           <p14:sldIdLst>
             <p14:sldId id="261"/>
             <p14:sldId id="262"/>
@@ -142,18 +142,18 @@
             <p14:sldId id="265"/>
           </p14:sldIdLst>
         </p14:section>
-        <p14:section name="Demo" id="{127973ab-7884-67ac-e78a-e8950d7c0a81}">
+        <p14:section name="Demo" id="{0628526a-2a65-76be-e070-cdd426fd5e00}">
           <p14:sldIdLst>
             <p14:sldId id="266"/>
           </p14:sldIdLst>
         </p14:section>
-        <p14:section name="Evidence" id="{8d7179cd-3d42-d5c8-bc96-a81938161765}">
+        <p14:section name="Evidence" id="{00692ff0-805c-92b4-ecce-852f3ea210bf}">
           <p14:sldIdLst>
             <p14:sldId id="267"/>
             <p14:sldId id="268"/>
           </p14:sldIdLst>
         </p14:section>
-        <p14:section name="Close" id="{22416e20-dac8-2a55-5d37-220dae28d772}">
+        <p14:section name="Close" id="{f54dc9e7-7e2a-066f-e298-e8cb8c429f0c}">
           <p14:sldIdLst>
             <p14:sldId id="269"/>
           </p14:sldIdLst>
@@ -1922,7 +1922,7 @@
           <a:p>
             <a:r>
               <a:rPr lang="en-US" dirty="0"/>
-              <a:t>Practise is where you learn: a two-minute session with live readings, one spoken correction at a time, and a scorecard that says how long the rate was actually measured. Emergency is one tap: the beat and spoken steps start immediately and never wait for the camera. Call 112 only opens the dialer, and there's an AED reminder at 30 seconds.</a:t>
+              <a:t>Practise is where you learn: a two-minute session with live readings, one spoken correction at a time, and a scorecard that says how long the rate was actually measured. Emergency is one tap: the beat and spoken steps start immediately and never wait for the camera. Call 112 only opens the dialer, and there's an AED reminder at 30 seconds. Both modes have run on a real phone: Practise on 7 real recordings, Emergency for steps, beat and dialer.</a:t>
             </a:r>
             <a:endParaRPr lang="en-US" dirty="0"/>
           </a:p>
@@ -3475,7 +3475,7 @@
             <a:r>
               <a:rPr lang="en-US" sz="2000" dirty="0">
                 <a:solidFill>
-                  <a:schemeClr val="bg2"/>
+                  <a:schemeClr val="bg1"/>
                 </a:solidFill>
               </a:rPr>
               <a:t>English is checked. The other nine are machine-translated and need native-speaker review.</a:t>
@@ -8732,7 +8732,7 @@
           </a:prstGeom>
           <a:solidFill>
             <a:srgbClr val="0E1418">
-              <a:alpha val="60000"/>
+              <a:alpha val="50000"/>
             </a:srgbClr>
           </a:solidFill>
           <a:ln/>
@@ -8824,7 +8824,7 @@
         <p:spPr>
           <a:xfrm>
             <a:off x="6099048" y="2286000"/>
-            <a:ext cx="0" cy="3657600"/>
+            <a:ext cx="0" cy="1554480"/>
           </a:xfrm>
           <a:prstGeom prst="line">
             <a:avLst/>
@@ -8925,79 +8925,6 @@
         <p:spPr>
           <a:xfrm>
             <a:off x="685800" y="3429000"/>
-            <a:ext cx="4754880" cy="1920240"/>
-          </a:xfrm>
-          <a:prstGeom prst="rect">
-            <a:avLst/>
-          </a:prstGeom>
-          <a:noFill/>
-          <a:ln/>
-        </p:spPr>
-        <p:txBody>
-          <a:bodyPr wrap="square" lIns="0" tIns="0" rIns="0" bIns="0" rtlCol="0" anchor="t"/>
-          <a:lstStyle/>
-          <a:p>
-            <a:pPr indent="0" marL="0">
-              <a:spcAft>
-                <a:spcPts val="1400"/>
-              </a:spcAft>
-              <a:buNone/>
-            </a:pPr>
-            <a:r>
-              <a:rPr lang="en-US" sz="2100" dirty="0">
-                <a:solidFill>
-                  <a:schemeClr val="bg1"/>
-                </a:solidFill>
-              </a:rPr>
-              <a:t>2-minute session, live readings</a:t>
-            </a:r>
-            <a:endParaRPr lang="en-US" sz="2100" dirty="0"/>
-          </a:p>
-          <a:p>
-            <a:pPr indent="0" marL="0">
-              <a:spcAft>
-                <a:spcPts val="1400"/>
-              </a:spcAft>
-              <a:buNone/>
-            </a:pPr>
-            <a:r>
-              <a:rPr lang="en-US" sz="2100" dirty="0">
-                <a:solidFill>
-                  <a:schemeClr val="bg1"/>
-                </a:solidFill>
-              </a:rPr>
-              <a:t>One spoken correction at a time</a:t>
-            </a:r>
-            <a:endParaRPr lang="en-US" sz="2100" dirty="0"/>
-          </a:p>
-          <a:p>
-            <a:pPr indent="0" marL="0">
-              <a:spcAft>
-                <a:spcPts val="1400"/>
-              </a:spcAft>
-              <a:buNone/>
-            </a:pPr>
-            <a:r>
-              <a:rPr lang="en-US" sz="2100" dirty="0">
-                <a:solidFill>
-                  <a:schemeClr val="bg1"/>
-                </a:solidFill>
-              </a:rPr>
-              <a:t>Scorecard shows how long rate was really measured</a:t>
-            </a:r>
-            <a:endParaRPr lang="en-US" sz="2100" dirty="0"/>
-          </a:p>
-        </p:txBody>
-      </p:sp>
-      <p:sp>
-        <p:nvSpPr>
-          <p:cNvPr id="9" name="Text 7"/>
-          <p:cNvSpPr txBox="1"/>
-          <p:nvPr/>
-        </p:nvSpPr>
-        <p:spPr>
-          <a:xfrm>
-            <a:off x="685800" y="5577840"/>
             <a:ext cx="4937760" cy="347472"/>
           </a:xfrm>
           <a:prstGeom prst="rect">
@@ -9030,7 +8957,7 @@
       </p:sp>
       <p:sp>
         <p:nvSpPr>
-          <p:cNvPr id="10" name="Text 8"/>
+          <p:cNvPr id="9" name="Text 7"/>
           <p:cNvSpPr txBox="1"/>
           <p:nvPr/>
         </p:nvSpPr>
@@ -9069,7 +8996,7 @@
       </p:sp>
       <p:sp>
         <p:nvSpPr>
-          <p:cNvPr id="11" name="Text 9"/>
+          <p:cNvPr id="10" name="Text 8"/>
           <p:cNvSpPr txBox="1"/>
           <p:nvPr/>
         </p:nvSpPr>
@@ -9108,86 +9035,13 @@
       </p:sp>
       <p:sp>
         <p:nvSpPr>
-          <p:cNvPr id="12" name="Text 10"/>
+          <p:cNvPr id="11" name="Text 9"/>
           <p:cNvSpPr txBox="1"/>
           <p:nvPr/>
         </p:nvSpPr>
         <p:spPr>
           <a:xfrm>
             <a:off x="6583680" y="3429000"/>
-            <a:ext cx="4754880" cy="1920240"/>
-          </a:xfrm>
-          <a:prstGeom prst="rect">
-            <a:avLst/>
-          </a:prstGeom>
-          <a:noFill/>
-          <a:ln/>
-        </p:spPr>
-        <p:txBody>
-          <a:bodyPr wrap="square" lIns="0" tIns="0" rIns="0" bIns="0" rtlCol="0" anchor="t"/>
-          <a:lstStyle/>
-          <a:p>
-            <a:pPr indent="0" marL="0">
-              <a:spcAft>
-                <a:spcPts val="1400"/>
-              </a:spcAft>
-              <a:buNone/>
-            </a:pPr>
-            <a:r>
-              <a:rPr lang="en-US" sz="2100" dirty="0">
-                <a:solidFill>
-                  <a:schemeClr val="bg1"/>
-                </a:solidFill>
-              </a:rPr>
-              <a:t>Beat and spoken steps start at once</a:t>
-            </a:r>
-            <a:endParaRPr lang="en-US" sz="2100" dirty="0"/>
-          </a:p>
-          <a:p>
-            <a:pPr indent="0" marL="0">
-              <a:spcAft>
-                <a:spcPts val="1400"/>
-              </a:spcAft>
-              <a:buNone/>
-            </a:pPr>
-            <a:r>
-              <a:rPr lang="en-US" sz="2100" dirty="0">
-                <a:solidFill>
-                  <a:schemeClr val="bg1"/>
-                </a:solidFill>
-              </a:rPr>
-              <a:t>Never waits for the camera</a:t>
-            </a:r>
-            <a:endParaRPr lang="en-US" sz="2100" dirty="0"/>
-          </a:p>
-          <a:p>
-            <a:pPr indent="0" marL="0">
-              <a:spcAft>
-                <a:spcPts val="1400"/>
-              </a:spcAft>
-              <a:buNone/>
-            </a:pPr>
-            <a:r>
-              <a:rPr lang="en-US" sz="2100" dirty="0">
-                <a:solidFill>
-                  <a:schemeClr val="bg1"/>
-                </a:solidFill>
-              </a:rPr>
-              <a:t>Call 112 opens the dialer; AED reminder at 30 s</a:t>
-            </a:r>
-            <a:endParaRPr lang="en-US" sz="2100" dirty="0"/>
-          </a:p>
-        </p:txBody>
-      </p:sp>
-      <p:sp>
-        <p:nvSpPr>
-          <p:cNvPr id="13" name="Text 11"/>
-          <p:cNvSpPr txBox="1"/>
-          <p:nvPr/>
-        </p:nvSpPr>
-        <p:spPr>
-          <a:xfrm>
-            <a:off x="6583680" y="5577840"/>
             <a:ext cx="4937760" cy="347472"/>
           </a:xfrm>
           <a:prstGeom prst="rect">

</xml_diff>

<commit_message>
deck v4: fixes from independent review (chest diagram, slide 9 title, close-slide contrast)
Co-Authored-By: Claude Opus 5.5 <noreply@anthropic.com>
Claude-Session: https://claude.ai/code/session_01CcKic77nKguzkLw3T8mxtp
</commit_message>
<xml_diff>
--- a/deck/CPR_Coach_Anvathon_2026_v4.pptx
+++ b/deck/CPR_Coach_Anvathon_2026_v4.pptx
@@ -120,12 +120,12 @@
   <p:extLst>
     <p:ext uri="{521415D9-36F7-43E2-AB2F-B90AF26B5E84}">
       <p14:sectionLst xmlns:p14="http://schemas.microsoft.com/office/powerpoint/2010/main">
-        <p14:section name="Opening" id="{8913b82e-b6ee-46e6-ec8d-61313e921939}">
+        <p14:section name="Opening" id="{b4aa96b9-fcac-c870-5f34-f0b84416a9ad}">
           <p14:sldIdLst>
             <p14:sldId id="256"/>
           </p14:sldIdLst>
         </p14:section>
-        <p14:section name="Problem" id="{a7b8e45b-d89e-3fd2-a8ac-b5ebde548a29}">
+        <p14:section name="Problem" id="{dd17c9ae-c484-1cff-42b4-4122563e6995}">
           <p14:sldIdLst>
             <p14:sldId id="257"/>
             <p14:sldId id="258"/>
@@ -133,7 +133,7 @@
             <p14:sldId id="260"/>
           </p14:sldIdLst>
         </p14:section>
-        <p14:section name="Solution" id="{d50a745f-bafc-b0dc-bd2f-b1f3c2595520}">
+        <p14:section name="Solution" id="{f03afea5-5816-1a41-d006-68572e2bacff}">
           <p14:sldIdLst>
             <p14:sldId id="261"/>
             <p14:sldId id="262"/>
@@ -142,18 +142,18 @@
             <p14:sldId id="265"/>
           </p14:sldIdLst>
         </p14:section>
-        <p14:section name="Demo" id="{0628526a-2a65-76be-e070-cdd426fd5e00}">
+        <p14:section name="Demo" id="{6b7f242b-8ea3-13d7-a0e4-a713515d4536}">
           <p14:sldIdLst>
             <p14:sldId id="266"/>
           </p14:sldIdLst>
         </p14:section>
-        <p14:section name="Evidence" id="{00692ff0-805c-92b4-ecce-852f3ea210bf}">
+        <p14:section name="Evidence" id="{c4358883-ade0-cf9c-4fda-6bc7ef8e7474}">
           <p14:sldIdLst>
             <p14:sldId id="267"/>
             <p14:sldId id="268"/>
           </p14:sldIdLst>
         </p14:section>
-        <p14:section name="Close" id="{f54dc9e7-7e2a-066f-e298-e8cb8c429f0c}">
+        <p14:section name="Close" id="{7a626a27-b78e-2f18-3ba5-5a4e3458c438}">
           <p14:sldIdLst>
             <p14:sldId id="269"/>
           </p14:sldIdLst>
@@ -5054,7 +5054,7 @@
             <a:r>
               <a:rPr lang="en-US" sz="2400" dirty="0">
                 <a:solidFill>
-                  <a:schemeClr val="bg2"/>
+                  <a:schemeClr val="bg1"/>
                 </a:solidFill>
               </a:rPr>
               <a:t>Then pilot it with NSS units, first-aid clubs and schools.</a:t>
@@ -5174,7 +5174,7 @@
             <a:r>
               <a:rPr lang="en-US" sz="1200" dirty="0">
                 <a:solidFill>
-                  <a:schemeClr val="bg2"/>
+                  <a:schemeClr val="bg1"/>
                 </a:solidFill>
                 <a:latin typeface="Consolas" pitchFamily="34" charset="0"/>
                 <a:ea typeface="Consolas" pitchFamily="34" charset="-122"/>
@@ -9180,7 +9180,7 @@
                 <a:ea typeface="Cambria" pitchFamily="34" charset="-122"/>
                 <a:cs typeface="Cambria" pitchFamily="34" charset="-120"/>
               </a:rPr>
-              <a:t>Push on the lower breastbone, arms straight, shoulders over hands</a:t>
+              <a:t>Good CPR needs three things; the app measures one of them</a:t>
             </a:r>
             <a:endParaRPr lang="en-US" sz="4000" dirty="0"/>
           </a:p>

</xml_diff>

<commit_message>
deck v4: subtle silhouette backgrounds on film slides
Co-Authored-By: Claude Opus 5.5 <noreply@anthropic.com>
Claude-Session: https://claude.ai/code/session_01CcKic77nKguzkLw3T8mxtp
</commit_message>
<xml_diff>
--- a/deck/CPR_Coach_Anvathon_2026_v4.pptx
+++ b/deck/CPR_Coach_Anvathon_2026_v4.pptx
@@ -120,12 +120,12 @@
   <p:extLst>
     <p:ext uri="{521415D9-36F7-43E2-AB2F-B90AF26B5E84}">
       <p14:sectionLst xmlns:p14="http://schemas.microsoft.com/office/powerpoint/2010/main">
-        <p14:section name="Opening" id="{b4aa96b9-fcac-c870-5f34-f0b84416a9ad}">
+        <p14:section name="Opening" id="{1bd0e748-0580-361e-b843-877927c9bd12}">
           <p14:sldIdLst>
             <p14:sldId id="256"/>
           </p14:sldIdLst>
         </p14:section>
-        <p14:section name="Problem" id="{dd17c9ae-c484-1cff-42b4-4122563e6995}">
+        <p14:section name="Problem" id="{c60119bb-4eea-f995-4bd0-4752f38d6dc0}">
           <p14:sldIdLst>
             <p14:sldId id="257"/>
             <p14:sldId id="258"/>
@@ -133,7 +133,7 @@
             <p14:sldId id="260"/>
           </p14:sldIdLst>
         </p14:section>
-        <p14:section name="Solution" id="{f03afea5-5816-1a41-d006-68572e2bacff}">
+        <p14:section name="Solution" id="{a9777522-e27b-02b6-4de8-6378ec2478c6}">
           <p14:sldIdLst>
             <p14:sldId id="261"/>
             <p14:sldId id="262"/>
@@ -142,18 +142,18 @@
             <p14:sldId id="265"/>
           </p14:sldIdLst>
         </p14:section>
-        <p14:section name="Demo" id="{6b7f242b-8ea3-13d7-a0e4-a713515d4536}">
+        <p14:section name="Demo" id="{9cd40d90-f825-0d73-74b0-83728a3265eb}">
           <p14:sldIdLst>
             <p14:sldId id="266"/>
           </p14:sldIdLst>
         </p14:section>
-        <p14:section name="Evidence" id="{c4358883-ade0-cf9c-4fda-6bc7ef8e7474}">
+        <p14:section name="Evidence" id="{6356be44-1314-a5f3-e91d-6599737b1751}">
           <p14:sldIdLst>
             <p14:sldId id="267"/>
             <p14:sldId id="268"/>
           </p14:sldIdLst>
         </p14:section>
-        <p14:section name="Close" id="{7a626a27-b78e-2f18-3ba5-5a4e3458c438}">
+        <p14:section name="Close" id="{5f873fb1-505d-f6ea-6c96-13442c316fff}">
           <p14:sldIdLst>
             <p14:sldId id="269"/>
           </p14:sldIdLst>
@@ -2652,7 +2652,7 @@
           </a:prstGeom>
           <a:solidFill>
             <a:srgbClr val="0E1418">
-              <a:alpha val="55000"/>
+              <a:alpha val="30000"/>
             </a:srgbClr>
           </a:solidFill>
           <a:ln/>
@@ -2975,7 +2975,7 @@
           </a:prstGeom>
           <a:solidFill>
             <a:srgbClr val="0E1418">
-              <a:alpha val="65000"/>
+              <a:alpha val="30000"/>
             </a:srgbClr>
           </a:solidFill>
           <a:ln/>
@@ -3587,7 +3587,7 @@
           </a:prstGeom>
           <a:solidFill>
             <a:srgbClr val="0E1418">
-              <a:alpha val="65000"/>
+              <a:alpha val="30000"/>
             </a:srgbClr>
           </a:solidFill>
           <a:ln/>
@@ -4927,7 +4927,7 @@
           </a:prstGeom>
           <a:solidFill>
             <a:srgbClr val="0E1418">
-              <a:alpha val="70000"/>
+              <a:alpha val="30000"/>
             </a:srgbClr>
           </a:solidFill>
           <a:ln/>
@@ -5383,7 +5383,7 @@
           </a:prstGeom>
           <a:solidFill>
             <a:srgbClr val="0E1418">
-              <a:alpha val="60000"/>
+              <a:alpha val="30000"/>
             </a:srgbClr>
           </a:solidFill>
           <a:ln/>
@@ -8732,7 +8732,7 @@
           </a:prstGeom>
           <a:solidFill>
             <a:srgbClr val="0E1418">
-              <a:alpha val="50000"/>
+              <a:alpha val="30000"/>
             </a:srgbClr>
           </a:solidFill>
           <a:ln/>

</xml_diff>